<commit_message>
Explain on the flash map why the primary slot crosses the bank boundary
The slide showed the crossing without saying where it comes from. Add a
callout with the derivation: 96 KB comes off the front for the RoT and
its data, so splitting the remaining 928 KB evenly lands 96 KB past the
0x80000 midpoint. Aligning the split to the bank instead would give
416 KB slots, 48 KB less in each, and buy nothing for the install since
MCUboot works in 8 KB pages and is unaware of banks - it only matters for
read-while-write and for any bank-swap scheme.

Add the same derivation to DOC.md, noting that the sw-crypto sibling uses
80 KB slots that fit inside bank 1 and only this variant grew them to
fill the device. Rebuild both decks.

Co-Authored-By: Claude Opus 5 <noreply@anthropic.com>
Claude-Session: https://claude.ai/code/session_01FwrRPd9LSvTbkxJ9rw1V8p
</commit_message>
<xml_diff>
--- a/examples/advanced/rot/oemirot_dualslot_hwcrypto/doc/diagrams/oemirot_architecture.pptx
+++ b/examples/advanced/rot/oemirot_dualslot_hwcrypto/doc/diagrams/oemirot_architecture.pptx
@@ -43907,6 +43907,334 @@
         </p:nvSpPr>
         <p:spPr>
           <a:xfrm>
+            <a:off x="8077200" y="4602480"/>
+            <a:ext cx="3627120" cy="1584960"/>
+          </a:xfrm>
+          <a:prstGeom prst="roundRect">
+            <a:avLst>
+              <a:gd name="adj" fmla="val 7692"/>
+            </a:avLst>
+          </a:prstGeom>
+          <a:solidFill>
+            <a:srgbClr val="FBE7E8"/>
+          </a:solidFill>
+          <a:ln w="18288">
+            <a:solidFill>
+              <a:srgbClr val="D0323C"/>
+            </a:solidFill>
+          </a:ln>
+          <a:effectLst/>
+        </p:spPr>
+        <p:style>
+          <a:lnRef idx="1">
+            <a:schemeClr val="accent1"/>
+          </a:lnRef>
+          <a:fillRef idx="3">
+            <a:schemeClr val="accent1"/>
+          </a:fillRef>
+          <a:effectRef idx="2">
+            <a:schemeClr val="accent1"/>
+          </a:effectRef>
+          <a:fontRef idx="minor">
+            <a:schemeClr val="lt1"/>
+          </a:fontRef>
+        </p:style>
+        <p:txBody>
+          <a:bodyPr rtlCol="0" anchor="ctr" wrap="none"/>
+          <a:lstStyle/>
+          <a:p>
+            <a:pPr algn="ctr"/>
+          </a:p>
+        </p:txBody>
+      </p:sp>
+      <p:sp>
+        <p:nvSpPr>
+          <p:cNvPr id="51" name="TextBox 50"/>
+          <p:cNvSpPr txBox="1"/>
+          <p:nvPr/>
+        </p:nvSpPr>
+        <p:spPr>
+          <a:xfrm>
+            <a:off x="8392973" y="4721657"/>
+            <a:ext cx="2995574" cy="240030"/>
+          </a:xfrm>
+          <a:prstGeom prst="rect">
+            <a:avLst/>
+          </a:prstGeom>
+          <a:noFill/>
+        </p:spPr>
+        <p:txBody>
+          <a:bodyPr wrap="square" lIns="0" rIns="0" tIns="0" bIns="0">
+            <a:noAutofit/>
+          </a:bodyPr>
+          <a:lstStyle/>
+          <a:p>
+            <a:pPr algn="ctr"/>
+            <a:r>
+              <a:rPr sz="1080" b="1">
+                <a:solidFill>
+                  <a:srgbClr val="D0323C"/>
+                </a:solidFill>
+                <a:latin typeface="Segoe UI"/>
+              </a:rPr>
+              <a:t>Why the primary slot crosses</a:t>
+            </a:r>
+          </a:p>
+        </p:txBody>
+      </p:sp>
+      <p:sp>
+        <p:nvSpPr>
+          <p:cNvPr id="52" name="TextBox 51"/>
+          <p:cNvSpPr txBox="1"/>
+          <p:nvPr/>
+        </p:nvSpPr>
+        <p:spPr>
+          <a:xfrm>
+            <a:off x="9195359" y="4889297"/>
+            <a:ext cx="1390802" cy="240030"/>
+          </a:xfrm>
+          <a:prstGeom prst="rect">
+            <a:avLst/>
+          </a:prstGeom>
+          <a:noFill/>
+        </p:spPr>
+        <p:txBody>
+          <a:bodyPr wrap="square" lIns="0" rIns="0" tIns="0" bIns="0">
+            <a:noAutofit/>
+          </a:bodyPr>
+          <a:lstStyle/>
+          <a:p>
+            <a:pPr algn="ctr"/>
+            <a:r>
+              <a:rPr sz="1080" b="1">
+                <a:solidFill>
+                  <a:srgbClr val="D0323C"/>
+                </a:solidFill>
+                <a:latin typeface="Segoe UI"/>
+              </a:rPr>
+              <a:t>the bank line</a:t>
+            </a:r>
+          </a:p>
+        </p:txBody>
+      </p:sp>
+      <p:sp>
+        <p:nvSpPr>
+          <p:cNvPr id="53" name="TextBox 52"/>
+          <p:cNvSpPr txBox="1"/>
+          <p:nvPr/>
+        </p:nvSpPr>
+        <p:spPr>
+          <a:xfrm>
+            <a:off x="8260080" y="5156454"/>
+            <a:ext cx="3374136" cy="200025"/>
+          </a:xfrm>
+          <a:prstGeom prst="rect">
+            <a:avLst/>
+          </a:prstGeom>
+          <a:noFill/>
+        </p:spPr>
+        <p:txBody>
+          <a:bodyPr wrap="square" lIns="0" rIns="0" tIns="0" bIns="0">
+            <a:noAutofit/>
+          </a:bodyPr>
+          <a:lstStyle/>
+          <a:p>
+            <a:pPr algn="l"/>
+            <a:r>
+              <a:rPr sz="900" b="0">
+                <a:solidFill>
+                  <a:srgbClr val="5B6B80"/>
+                </a:solidFill>
+                <a:latin typeface="Segoe UI"/>
+              </a:rPr>
+              <a:t>96 KB comes off the front for the RoT, so</a:t>
+            </a:r>
+          </a:p>
+        </p:txBody>
+      </p:sp>
+      <p:sp>
+        <p:nvSpPr>
+          <p:cNvPr id="54" name="TextBox 53"/>
+          <p:cNvSpPr txBox="1"/>
+          <p:nvPr/>
+        </p:nvSpPr>
+        <p:spPr>
+          <a:xfrm>
+            <a:off x="8260080" y="5316474"/>
+            <a:ext cx="3621024" cy="200025"/>
+          </a:xfrm>
+          <a:prstGeom prst="rect">
+            <a:avLst/>
+          </a:prstGeom>
+          <a:noFill/>
+        </p:spPr>
+        <p:txBody>
+          <a:bodyPr wrap="square" lIns="0" rIns="0" tIns="0" bIns="0">
+            <a:noAutofit/>
+          </a:bodyPr>
+          <a:lstStyle/>
+          <a:p>
+            <a:pPr algn="l"/>
+            <a:r>
+              <a:rPr sz="900" b="0">
+                <a:solidFill>
+                  <a:srgbClr val="5B6B80"/>
+                </a:solidFill>
+                <a:latin typeface="Segoe UI"/>
+              </a:rPr>
+              <a:t>splitting the remaining 928 KB in half lands</a:t>
+            </a:r>
+          </a:p>
+        </p:txBody>
+      </p:sp>
+      <p:sp>
+        <p:nvSpPr>
+          <p:cNvPr id="55" name="TextBox 54"/>
+          <p:cNvSpPr txBox="1"/>
+          <p:nvPr/>
+        </p:nvSpPr>
+        <p:spPr>
+          <a:xfrm>
+            <a:off x="8260080" y="5476494"/>
+            <a:ext cx="3374136" cy="200025"/>
+          </a:xfrm>
+          <a:prstGeom prst="rect">
+            <a:avLst/>
+          </a:prstGeom>
+          <a:noFill/>
+        </p:spPr>
+        <p:txBody>
+          <a:bodyPr wrap="square" lIns="0" rIns="0" tIns="0" bIns="0">
+            <a:noAutofit/>
+          </a:bodyPr>
+          <a:lstStyle/>
+          <a:p>
+            <a:pPr algn="l"/>
+            <a:r>
+              <a:rPr sz="900" b="0">
+                <a:solidFill>
+                  <a:srgbClr val="5B6B80"/>
+                </a:solidFill>
+                <a:latin typeface="Segoe UI"/>
+              </a:rPr>
+              <a:t>96 KB past the 0x80000 midpoint. Aligning</a:t>
+            </a:r>
+          </a:p>
+        </p:txBody>
+      </p:sp>
+      <p:sp>
+        <p:nvSpPr>
+          <p:cNvPr id="56" name="TextBox 55"/>
+          <p:cNvSpPr txBox="1"/>
+          <p:nvPr/>
+        </p:nvSpPr>
+        <p:spPr>
+          <a:xfrm>
+            <a:off x="8260080" y="5636514"/>
+            <a:ext cx="3044952" cy="200025"/>
+          </a:xfrm>
+          <a:prstGeom prst="rect">
+            <a:avLst/>
+          </a:prstGeom>
+          <a:noFill/>
+        </p:spPr>
+        <p:txBody>
+          <a:bodyPr wrap="square" lIns="0" rIns="0" tIns="0" bIns="0">
+            <a:noAutofit/>
+          </a:bodyPr>
+          <a:lstStyle/>
+          <a:p>
+            <a:pPr algn="l"/>
+            <a:r>
+              <a:rPr sz="900" b="0">
+                <a:solidFill>
+                  <a:srgbClr val="5B6B80"/>
+                </a:solidFill>
+                <a:latin typeface="Segoe UI"/>
+              </a:rPr>
+              <a:t>to the bank instead would mean 416 KB</a:t>
+            </a:r>
+          </a:p>
+        </p:txBody>
+      </p:sp>
+      <p:sp>
+        <p:nvSpPr>
+          <p:cNvPr id="57" name="TextBox 56"/>
+          <p:cNvSpPr txBox="1"/>
+          <p:nvPr/>
+        </p:nvSpPr>
+        <p:spPr>
+          <a:xfrm>
+            <a:off x="8260080" y="5796534"/>
+            <a:ext cx="2221992" cy="200025"/>
+          </a:xfrm>
+          <a:prstGeom prst="rect">
+            <a:avLst/>
+          </a:prstGeom>
+          <a:noFill/>
+        </p:spPr>
+        <p:txBody>
+          <a:bodyPr wrap="square" lIns="0" rIns="0" tIns="0" bIns="0">
+            <a:noAutofit/>
+          </a:bodyPr>
+          <a:lstStyle/>
+          <a:p>
+            <a:pPr algn="l"/>
+            <a:r>
+              <a:rPr sz="900" b="0">
+                <a:solidFill>
+                  <a:srgbClr val="5B6B80"/>
+                </a:solidFill>
+                <a:latin typeface="Segoe UI"/>
+              </a:rPr>
+              <a:t>slots — 48 KB less in each.</a:t>
+            </a:r>
+          </a:p>
+        </p:txBody>
+      </p:sp>
+      <p:sp>
+        <p:nvSpPr>
+          <p:cNvPr id="58" name="TextBox 57"/>
+          <p:cNvSpPr txBox="1"/>
+          <p:nvPr/>
+        </p:nvSpPr>
+        <p:spPr>
+          <a:xfrm>
+            <a:off x="8260080" y="5994959"/>
+            <a:ext cx="4172407" cy="173355"/>
+          </a:xfrm>
+          <a:prstGeom prst="rect">
+            <a:avLst/>
+          </a:prstGeom>
+          <a:noFill/>
+        </p:spPr>
+        <p:txBody>
+          <a:bodyPr wrap="square" lIns="0" rIns="0" tIns="0" bIns="0">
+            <a:noAutofit/>
+          </a:bodyPr>
+          <a:lstStyle/>
+          <a:p>
+            <a:pPr algn="l"/>
+            <a:r>
+              <a:rPr sz="780" b="1">
+                <a:solidFill>
+                  <a:srgbClr val="D0323C"/>
+                </a:solidFill>
+                <a:latin typeface="Segoe UI"/>
+              </a:rPr>
+              <a:t>Harmless for the install — it bites RWW and bank swap.</a:t>
+            </a:r>
+          </a:p>
+        </p:txBody>
+      </p:sp>
+      <p:sp>
+        <p:nvSpPr>
+          <p:cNvPr id="59" name="Rounded Rectangle 58"/>
+          <p:cNvSpPr/>
+          <p:nvPr/>
+        </p:nvSpPr>
+        <p:spPr>
+          <a:xfrm>
             <a:off x="487680" y="6339840"/>
             <a:ext cx="11216640" cy="15240"/>
           </a:xfrm>
@@ -43947,7 +44275,7 @@
       </p:sp>
       <p:sp>
         <p:nvSpPr>
-          <p:cNvPr id="51" name="TextBox 50"/>
+          <p:cNvPr id="60" name="TextBox 59"/>
           <p:cNvSpPr txBox="1"/>
           <p:nvPr/>
         </p:nvSpPr>

</xml_diff>

<commit_message>
Move the bank-crossing callout next to the bank divider
The explanation was in the lower-right corner of the flash-map slide,
far from the red bank line it explains and below the fold when the slide
is viewed part-scrolled. Move it alongside the memory bar, connect it to
the divider with a dashed leader, and shorten the WRP/HDP label leaders
to free that space. Placed below the slot size labels so it does not
cover the secondary slot's "464 KB".

Verified in both decks by rendering the editable one through LibreOffice.

Co-Authored-By: Claude Opus 5 <noreply@anthropic.com>
Claude-Session: https://claude.ai/code/session_01FwrRPd9LSvTbkxJ9rw1V8p
</commit_message>
<xml_diff>
--- a/examples/advanced/rot/oemirot_dualslot_hwcrypto/doc/diagrams/oemirot_architecture.pptx
+++ b/examples/advanced/rot/oemirot_dualslot_hwcrypto/doc/diagrams/oemirot_architecture.pptx
@@ -43145,7 +43145,7 @@
         <p:spPr>
           <a:xfrm>
             <a:off x="1424940" y="3352800"/>
-            <a:ext cx="3360420" cy="0"/>
+            <a:ext cx="1836420" cy="0"/>
           </a:xfrm>
           <a:prstGeom prst="line">
             <a:avLst/>
@@ -43180,7 +43180,7 @@
         </p:nvSpPr>
         <p:spPr>
           <a:xfrm>
-            <a:off x="4876800" y="3258617"/>
+            <a:off x="3352800" y="3258617"/>
             <a:ext cx="3530498" cy="240030"/>
           </a:xfrm>
           <a:prstGeom prst="rect">
@@ -43321,7 +43321,7 @@
         <p:spPr>
           <a:xfrm>
             <a:off x="1600200" y="3794760"/>
-            <a:ext cx="3185160" cy="0"/>
+            <a:ext cx="1661160" cy="0"/>
           </a:xfrm>
           <a:prstGeom prst="line">
             <a:avLst/>
@@ -43356,7 +43356,7 @@
         </p:nvSpPr>
         <p:spPr>
           <a:xfrm>
-            <a:off x="4876800" y="3700577"/>
+            <a:off x="3352800" y="3700577"/>
             <a:ext cx="4386377" cy="240030"/>
           </a:xfrm>
           <a:prstGeom prst="rect">
@@ -43899,15 +43899,88 @@
           </a:p>
         </p:txBody>
       </p:sp>
-      <p:sp>
-        <p:nvSpPr>
-          <p:cNvPr id="50" name="Rounded Rectangle 49"/>
+      <p:cxnSp>
+        <p:nvCxnSpPr>
+          <p:cNvPr id="50" name="Connector 49"/>
+          <p:cNvCxnSpPr/>
+          <p:nvPr/>
+        </p:nvCxnSpPr>
+        <p:spPr>
+          <a:xfrm>
+            <a:off x="6126480" y="2773680"/>
+            <a:ext cx="1341120" cy="1021080"/>
+          </a:xfrm>
+          <a:prstGeom prst="line">
+            <a:avLst/>
+          </a:prstGeom>
+          <a:ln w="16764">
+            <a:solidFill>
+              <a:srgbClr val="D0323C"/>
+            </a:solidFill>
+            <a:prstDash val="dash"/>
+          </a:ln>
+        </p:spPr>
+        <p:style>
+          <a:lnRef idx="2">
+            <a:schemeClr val="accent1"/>
+          </a:lnRef>
+          <a:fillRef idx="0">
+            <a:schemeClr val="accent1"/>
+          </a:fillRef>
+          <a:effectRef idx="1">
+            <a:schemeClr val="accent1"/>
+          </a:effectRef>
+          <a:fontRef idx="minor">
+            <a:schemeClr val="tx1"/>
+          </a:fontRef>
+        </p:style>
+      </p:cxnSp>
+      <p:cxnSp>
+        <p:nvCxnSpPr>
+          <p:cNvPr id="51" name="Connector 50"/>
+          <p:cNvCxnSpPr/>
+          <p:nvPr/>
+        </p:nvCxnSpPr>
+        <p:spPr>
+          <a:xfrm>
+            <a:off x="7467600" y="3794760"/>
+            <a:ext cx="548640" cy="0"/>
+          </a:xfrm>
+          <a:prstGeom prst="line">
+            <a:avLst/>
+          </a:prstGeom>
+          <a:ln w="16764">
+            <a:solidFill>
+              <a:srgbClr val="D0323C"/>
+            </a:solidFill>
+            <a:prstDash val="dash"/>
+            <a:tailEnd type="triangle" w="med" len="med"/>
+          </a:ln>
+        </p:spPr>
+        <p:style>
+          <a:lnRef idx="2">
+            <a:schemeClr val="accent1"/>
+          </a:lnRef>
+          <a:fillRef idx="0">
+            <a:schemeClr val="accent1"/>
+          </a:fillRef>
+          <a:effectRef idx="1">
+            <a:schemeClr val="accent1"/>
+          </a:effectRef>
+          <a:fontRef idx="minor">
+            <a:schemeClr val="tx1"/>
+          </a:fontRef>
+        </p:style>
+      </p:cxnSp>
+      <p:sp>
+        <p:nvSpPr>
+          <p:cNvPr id="52" name="Rounded Rectangle 51"/>
           <p:cNvSpPr/>
           <p:nvPr/>
         </p:nvSpPr>
         <p:spPr>
           <a:xfrm>
-            <a:off x="8077200" y="4602480"/>
+            <a:off x="8077200" y="3230880"/>
             <a:ext cx="3627120" cy="1584960"/>
           </a:xfrm>
           <a:prstGeom prst="roundRect">
@@ -43949,13 +44022,13 @@
       </p:sp>
       <p:sp>
         <p:nvSpPr>
-          <p:cNvPr id="51" name="TextBox 50"/>
-          <p:cNvSpPr txBox="1"/>
-          <p:nvPr/>
-        </p:nvSpPr>
-        <p:spPr>
-          <a:xfrm>
-            <a:off x="8392973" y="4721657"/>
+          <p:cNvPr id="53" name="TextBox 52"/>
+          <p:cNvSpPr txBox="1"/>
+          <p:nvPr/>
+        </p:nvSpPr>
+        <p:spPr>
+          <a:xfrm>
+            <a:off x="8392973" y="3350057"/>
             <a:ext cx="2995574" cy="240030"/>
           </a:xfrm>
           <a:prstGeom prst="rect">
@@ -43984,13 +44057,13 @@
       </p:sp>
       <p:sp>
         <p:nvSpPr>
-          <p:cNvPr id="52" name="TextBox 51"/>
-          <p:cNvSpPr txBox="1"/>
-          <p:nvPr/>
-        </p:nvSpPr>
-        <p:spPr>
-          <a:xfrm>
-            <a:off x="9195359" y="4889297"/>
+          <p:cNvPr id="54" name="TextBox 53"/>
+          <p:cNvSpPr txBox="1"/>
+          <p:nvPr/>
+        </p:nvSpPr>
+        <p:spPr>
+          <a:xfrm>
+            <a:off x="9195359" y="3517697"/>
             <a:ext cx="1390802" cy="240030"/>
           </a:xfrm>
           <a:prstGeom prst="rect">
@@ -44019,13 +44092,13 @@
       </p:sp>
       <p:sp>
         <p:nvSpPr>
-          <p:cNvPr id="53" name="TextBox 52"/>
-          <p:cNvSpPr txBox="1"/>
-          <p:nvPr/>
-        </p:nvSpPr>
-        <p:spPr>
-          <a:xfrm>
-            <a:off x="8260080" y="5156454"/>
+          <p:cNvPr id="55" name="TextBox 54"/>
+          <p:cNvSpPr txBox="1"/>
+          <p:nvPr/>
+        </p:nvSpPr>
+        <p:spPr>
+          <a:xfrm>
+            <a:off x="8260080" y="3784854"/>
             <a:ext cx="3374136" cy="200025"/>
           </a:xfrm>
           <a:prstGeom prst="rect">
@@ -44054,13 +44127,13 @@
       </p:sp>
       <p:sp>
         <p:nvSpPr>
-          <p:cNvPr id="54" name="TextBox 53"/>
-          <p:cNvSpPr txBox="1"/>
-          <p:nvPr/>
-        </p:nvSpPr>
-        <p:spPr>
-          <a:xfrm>
-            <a:off x="8260080" y="5316474"/>
+          <p:cNvPr id="56" name="TextBox 55"/>
+          <p:cNvSpPr txBox="1"/>
+          <p:nvPr/>
+        </p:nvSpPr>
+        <p:spPr>
+          <a:xfrm>
+            <a:off x="8260080" y="3944874"/>
             <a:ext cx="3621024" cy="200025"/>
           </a:xfrm>
           <a:prstGeom prst="rect">
@@ -44089,13 +44162,13 @@
       </p:sp>
       <p:sp>
         <p:nvSpPr>
-          <p:cNvPr id="55" name="TextBox 54"/>
-          <p:cNvSpPr txBox="1"/>
-          <p:nvPr/>
-        </p:nvSpPr>
-        <p:spPr>
-          <a:xfrm>
-            <a:off x="8260080" y="5476494"/>
+          <p:cNvPr id="57" name="TextBox 56"/>
+          <p:cNvSpPr txBox="1"/>
+          <p:nvPr/>
+        </p:nvSpPr>
+        <p:spPr>
+          <a:xfrm>
+            <a:off x="8260080" y="4104894"/>
             <a:ext cx="3374136" cy="200025"/>
           </a:xfrm>
           <a:prstGeom prst="rect">
@@ -44124,13 +44197,13 @@
       </p:sp>
       <p:sp>
         <p:nvSpPr>
-          <p:cNvPr id="56" name="TextBox 55"/>
-          <p:cNvSpPr txBox="1"/>
-          <p:nvPr/>
-        </p:nvSpPr>
-        <p:spPr>
-          <a:xfrm>
-            <a:off x="8260080" y="5636514"/>
+          <p:cNvPr id="58" name="TextBox 57"/>
+          <p:cNvSpPr txBox="1"/>
+          <p:nvPr/>
+        </p:nvSpPr>
+        <p:spPr>
+          <a:xfrm>
+            <a:off x="8260080" y="4264914"/>
             <a:ext cx="3044952" cy="200025"/>
           </a:xfrm>
           <a:prstGeom prst="rect">
@@ -44159,13 +44232,13 @@
       </p:sp>
       <p:sp>
         <p:nvSpPr>
-          <p:cNvPr id="57" name="TextBox 56"/>
-          <p:cNvSpPr txBox="1"/>
-          <p:nvPr/>
-        </p:nvSpPr>
-        <p:spPr>
-          <a:xfrm>
-            <a:off x="8260080" y="5796534"/>
+          <p:cNvPr id="59" name="TextBox 58"/>
+          <p:cNvSpPr txBox="1"/>
+          <p:nvPr/>
+        </p:nvSpPr>
+        <p:spPr>
+          <a:xfrm>
+            <a:off x="8260080" y="4424934"/>
             <a:ext cx="2221992" cy="200025"/>
           </a:xfrm>
           <a:prstGeom prst="rect">
@@ -44194,13 +44267,13 @@
       </p:sp>
       <p:sp>
         <p:nvSpPr>
-          <p:cNvPr id="58" name="TextBox 57"/>
-          <p:cNvSpPr txBox="1"/>
-          <p:nvPr/>
-        </p:nvSpPr>
-        <p:spPr>
-          <a:xfrm>
-            <a:off x="8260080" y="5994959"/>
+          <p:cNvPr id="60" name="TextBox 59"/>
+          <p:cNvSpPr txBox="1"/>
+          <p:nvPr/>
+        </p:nvSpPr>
+        <p:spPr>
+          <a:xfrm>
+            <a:off x="8260080" y="4623359"/>
             <a:ext cx="4172407" cy="173355"/>
           </a:xfrm>
           <a:prstGeom prst="rect">
@@ -44229,7 +44302,7 @@
       </p:sp>
       <p:sp>
         <p:nvSpPr>
-          <p:cNvPr id="59" name="Rounded Rectangle 58"/>
+          <p:cNvPr id="61" name="Rounded Rectangle 60"/>
           <p:cNvSpPr/>
           <p:nvPr/>
         </p:nvSpPr>
@@ -44275,7 +44348,7 @@
       </p:sp>
       <p:sp>
         <p:nvSpPr>
-          <p:cNvPr id="60" name="TextBox 59"/>
+          <p:cNvPr id="62" name="TextBox 61"/>
           <p:cNvSpPr txBox="1"/>
           <p:nvPr/>
         </p:nvSpPr>

</xml_diff>